<commit_message>
feat(branding): update brand identity to Finova (intelligent Fintech) with logo asset, UI components, backend prompt, and docs
</commit_message>
<xml_diff>
--- a/presentation.pptx
+++ b/presentation.pptx
@@ -7,9 +7,6 @@
   <p:sldIdLst>
     <p:sldId id="256" r:id="rId7"/>
     <p:sldId id="257" r:id="rId8"/>
-    <p:sldId id="258" r:id="rId9"/>
-    <p:sldId id="259" r:id="rId10"/>
-    <p:sldId id="260" r:id="rId11"/>
   </p:sldIdLst>
   <p:sldSz cx="12188952" cy="6858000" type="screen4x3"/>
   <p:notesSz cx="6858000" cy="9144000"/>
@@ -3130,7 +3127,7 @@
               </a:defRPr>
             </a:pPr>
             <a:r>
-              <a:t>✦ FINLY</a:t>
+              <a:t>✦ Finova</a:t>
             </a:r>
           </a:p>
           <a:p>
@@ -3142,7 +3139,7 @@
               </a:defRPr>
             </a:pPr>
             <a:r>
-              <a:t>Smart Expense Analyzer &amp; Financial Health Dashboard with AI Agent</a:t>
+              <a:t>Intelligent Fintech &amp; Smart Expense Analyzer with AI Agent</a:t>
             </a:r>
           </a:p>
           <a:p>
@@ -3216,7 +3213,7 @@
               </a:defRPr>
             </a:pPr>
             <a:r>
-              <a:t>FINLY — SMART EXPENSE ANALYZER &amp; FINANCIAL HEALTH DASHBOARD</a:t>
+              <a:t>FINOVA — INTELLIGENT FINTECH PLATFORM</a:t>
             </a:r>
           </a:p>
           <a:p>
@@ -3275,7 +3272,7 @@
               </a:defRPr>
             </a:pPr>
             <a:r>
-              <a:t>• Unstructured CSV bank statements with messy merchant names.</a:t>
+              <a:t>• Unstructured bank statement CSVs with messy merchant names.</a:t>
             </a:r>
           </a:p>
           <a:p>
@@ -3346,7 +3343,7 @@
               </a:defRPr>
             </a:pPr>
             <a:r>
-              <a:t>💡 The FINLY Solution</a:t>
+              <a:t>💡 The Finova Solution</a:t>
             </a:r>
           </a:p>
           <a:p>
@@ -3407,501 +3404,6 @@
             </a:pPr>
             <a:r>
               <a:t>• Zero key exposure &amp; strict multi-tenant user data isolation.</a:t>
-            </a:r>
-          </a:p>
-        </p:txBody>
-      </p:sp>
-    </p:spTree>
-  </p:cSld>
-  <p:clrMapOvr>
-    <a:masterClrMapping/>
-  </p:clrMapOvr>
-</p:sld>
-</file>
-
-<file path=ppt/slides/slide3.xml><?xml version="1.0" encoding="utf-8"?>
-<p:sld xmlns:a="http://schemas.openxmlformats.org/drawingml/2006/main" xmlns:p="http://schemas.openxmlformats.org/presentationml/2006/main" xmlns:r="http://schemas.openxmlformats.org/officeDocument/2006/relationships">
-  <p:cSld>
-    <p:bg>
-      <p:bgPr>
-        <a:solidFill>
-          <a:srgbClr val="0F172A"/>
-        </a:solidFill>
-        <a:effectLst/>
-      </p:bgPr>
-    </p:bg>
-    <p:spTree>
-      <p:nvGrpSpPr>
-        <p:cNvPr id="1" name=""/>
-        <p:cNvGrpSpPr/>
-        <p:nvPr/>
-      </p:nvGrpSpPr>
-      <p:grpSpPr/>
-      <p:sp>
-        <p:nvSpPr>
-          <p:cNvPr id="2" name="TextBox 1"/>
-          <p:cNvSpPr txBox="1"/>
-          <p:nvPr/>
-        </p:nvSpPr>
-        <p:spPr>
-          <a:xfrm>
-            <a:off x="731520" y="457200"/>
-            <a:ext cx="10698480" cy="1097280"/>
-          </a:xfrm>
-          <a:prstGeom prst="rect">
-            <a:avLst/>
-          </a:prstGeom>
-          <a:noFill/>
-        </p:spPr>
-        <p:txBody>
-          <a:bodyPr wrap="square">
-            <a:spAutoFit/>
-          </a:bodyPr>
-          <a:lstStyle/>
-          <a:p>
-            <a:pPr>
-              <a:defRPr sz="1200" b="1">
-                <a:solidFill>
-                  <a:srgbClr val="C084FC"/>
-                </a:solidFill>
-              </a:defRPr>
-            </a:pPr>
-            <a:r>
-              <a:t>FINLY — SMART EXPENSE ANALYZER &amp; FINANCIAL HEALTH DASHBOARD</a:t>
-            </a:r>
-          </a:p>
-          <a:p>
-            <a:pPr>
-              <a:defRPr sz="2800" b="1">
-                <a:solidFill>
-                  <a:srgbClr val="F8FAFC"/>
-                </a:solidFill>
-              </a:defRPr>
-            </a:pPr>
-            <a:r>
-              <a:t>AI Agent Architecture (Groq LLM + Tool Calling)</a:t>
-            </a:r>
-          </a:p>
-        </p:txBody>
-      </p:sp>
-      <p:sp>
-        <p:nvSpPr>
-          <p:cNvPr id="3" name="TextBox 2"/>
-          <p:cNvSpPr txBox="1"/>
-          <p:nvPr/>
-        </p:nvSpPr>
-        <p:spPr>
-          <a:xfrm>
-            <a:off x="731520" y="1828800"/>
-            <a:ext cx="10698480" cy="4389120"/>
-          </a:xfrm>
-          <a:prstGeom prst="rect">
-            <a:avLst/>
-          </a:prstGeom>
-          <a:noFill/>
-        </p:spPr>
-        <p:txBody>
-          <a:bodyPr wrap="square">
-            <a:spAutoFit/>
-          </a:bodyPr>
-          <a:lstStyle/>
-          <a:p/>
-          <a:p>
-            <a:pPr>
-              <a:defRPr sz="1600">
-                <a:solidFill>
-                  <a:srgbClr val="F8FAFC"/>
-                </a:solidFill>
-              </a:defRPr>
-            </a:pPr>
-            <a:r>
-              <a:t>✔ User Query ➔ Floating AI Copilot Panel (bottom-right UI)</a:t>
-            </a:r>
-          </a:p>
-          <a:p>
-            <a:pPr>
-              <a:defRPr sz="1600">
-                <a:solidFill>
-                  <a:srgbClr val="F8FAFC"/>
-                </a:solidFill>
-              </a:defRPr>
-            </a:pPr>
-            <a:r>
-              <a:t>✔ Backend Express Server ➔ POST /api/agent/chat (Session validated)</a:t>
-            </a:r>
-          </a:p>
-          <a:p>
-            <a:pPr>
-              <a:defRPr sz="1600">
-                <a:solidFill>
-                  <a:srgbClr val="F8FAFC"/>
-                </a:solidFill>
-              </a:defRPr>
-            </a:pPr>
-            <a:r>
-              <a:t>✔ Groq Model Selection ➔ llama-3.3-70b-versatile (Sub-second response)</a:t>
-            </a:r>
-          </a:p>
-          <a:p>
-            <a:pPr>
-              <a:defRPr sz="1600">
-                <a:solidFill>
-                  <a:srgbClr val="F8FAFC"/>
-                </a:solidFill>
-              </a:defRPr>
-            </a:pPr>
-            <a:r>
-              <a:t>✔ Function Tool Execution ➔ backend/agent/tools/ (18 registered tools)</a:t>
-            </a:r>
-          </a:p>
-          <a:p>
-            <a:pPr>
-              <a:defRPr sz="1600">
-                <a:solidFill>
-                  <a:srgbClr val="F8FAFC"/>
-                </a:solidFill>
-              </a:defRPr>
-            </a:pPr>
-            <a:r>
-              <a:t>✔ Grounding Guarantee ➔ Tool outputs are absolute source of truth (no hallucinated figures)</a:t>
-            </a:r>
-          </a:p>
-          <a:p>
-            <a:pPr>
-              <a:defRPr sz="1600">
-                <a:solidFill>
-                  <a:srgbClr val="F8FAFC"/>
-                </a:solidFill>
-              </a:defRPr>
-            </a:pPr>
-            <a:r>
-              <a:t>✔ Graceful Fallback Engine ➔ Automatic fallback if LLM credentials are unavailable</a:t>
-            </a:r>
-          </a:p>
-        </p:txBody>
-      </p:sp>
-    </p:spTree>
-  </p:cSld>
-  <p:clrMapOvr>
-    <a:masterClrMapping/>
-  </p:clrMapOvr>
-</p:sld>
-</file>
-
-<file path=ppt/slides/slide4.xml><?xml version="1.0" encoding="utf-8"?>
-<p:sld xmlns:a="http://schemas.openxmlformats.org/drawingml/2006/main" xmlns:p="http://schemas.openxmlformats.org/presentationml/2006/main" xmlns:r="http://schemas.openxmlformats.org/officeDocument/2006/relationships">
-  <p:cSld>
-    <p:bg>
-      <p:bgPr>
-        <a:solidFill>
-          <a:srgbClr val="0F172A"/>
-        </a:solidFill>
-        <a:effectLst/>
-      </p:bgPr>
-    </p:bg>
-    <p:spTree>
-      <p:nvGrpSpPr>
-        <p:cNvPr id="1" name=""/>
-        <p:cNvGrpSpPr/>
-        <p:nvPr/>
-      </p:nvGrpSpPr>
-      <p:grpSpPr/>
-      <p:sp>
-        <p:nvSpPr>
-          <p:cNvPr id="2" name="TextBox 1"/>
-          <p:cNvSpPr txBox="1"/>
-          <p:nvPr/>
-        </p:nvSpPr>
-        <p:spPr>
-          <a:xfrm>
-            <a:off x="731520" y="457200"/>
-            <a:ext cx="10698480" cy="1097280"/>
-          </a:xfrm>
-          <a:prstGeom prst="rect">
-            <a:avLst/>
-          </a:prstGeom>
-          <a:noFill/>
-        </p:spPr>
-        <p:txBody>
-          <a:bodyPr wrap="square">
-            <a:spAutoFit/>
-          </a:bodyPr>
-          <a:lstStyle/>
-          <a:p>
-            <a:pPr>
-              <a:defRPr sz="1200" b="1">
-                <a:solidFill>
-                  <a:srgbClr val="C084FC"/>
-                </a:solidFill>
-              </a:defRPr>
-            </a:pPr>
-            <a:r>
-              <a:t>FINLY — SMART EXPENSE ANALYZER &amp; FINANCIAL HEALTH DASHBOARD</a:t>
-            </a:r>
-          </a:p>
-          <a:p>
-            <a:pPr>
-              <a:defRPr sz="2800" b="1">
-                <a:solidFill>
-                  <a:srgbClr val="F8FAFC"/>
-                </a:solidFill>
-              </a:defRPr>
-            </a:pPr>
-            <a:r>
-              <a:t>Product Module Capabilities</a:t>
-            </a:r>
-          </a:p>
-        </p:txBody>
-      </p:sp>
-      <p:sp>
-        <p:nvSpPr>
-          <p:cNvPr id="3" name="TextBox 2"/>
-          <p:cNvSpPr txBox="1"/>
-          <p:nvPr/>
-        </p:nvSpPr>
-        <p:spPr>
-          <a:xfrm>
-            <a:off x="731520" y="1828800"/>
-            <a:ext cx="10698480" cy="4389120"/>
-          </a:xfrm>
-          <a:prstGeom prst="rect">
-            <a:avLst/>
-          </a:prstGeom>
-          <a:noFill/>
-        </p:spPr>
-        <p:txBody>
-          <a:bodyPr wrap="square">
-            <a:spAutoFit/>
-          </a:bodyPr>
-          <a:lstStyle/>
-          <a:p/>
-          <a:p>
-            <a:pPr>
-              <a:defRPr sz="1500">
-                <a:solidFill>
-                  <a:srgbClr val="F8FAFC"/>
-                </a:solidFill>
-              </a:defRPr>
-            </a:pPr>
-            <a:r>
-              <a:t>1. Dashboard: Real-time net cashflow, category charts, recent transactions.</a:t>
-            </a:r>
-          </a:p>
-          <a:p>
-            <a:pPr>
-              <a:defRPr sz="1500">
-                <a:solidFill>
-                  <a:srgbClr val="F8FAFC"/>
-                </a:solidFill>
-              </a:defRPr>
-            </a:pPr>
-            <a:r>
-              <a:t>2. Ingestion: Bank CSV upload with auto-mapping &amp; manual single-entry form.</a:t>
-            </a:r>
-          </a:p>
-          <a:p>
-            <a:pPr>
-              <a:defRPr sz="1500">
-                <a:solidFill>
-                  <a:srgbClr val="F8FAFC"/>
-                </a:solidFill>
-              </a:defRPr>
-            </a:pPr>
-            <a:r>
-              <a:t>3. Data Cleaning: Smart deduplication algorithm and merchant normalization.</a:t>
-            </a:r>
-          </a:p>
-          <a:p>
-            <a:pPr>
-              <a:defRPr sz="1500">
-                <a:solidFill>
-                  <a:srgbClr val="F8FAFC"/>
-                </a:solidFill>
-              </a:defRPr>
-            </a:pPr>
-            <a:r>
-              <a:t>4. Intelligence: Financial Health Score (0-100), grade (A-D), and money leak detector.</a:t>
-            </a:r>
-          </a:p>
-          <a:p>
-            <a:pPr>
-              <a:defRPr sz="1500">
-                <a:solidFill>
-                  <a:srgbClr val="F8FAFC"/>
-                </a:solidFill>
-              </a:defRPr>
-            </a:pPr>
-            <a:r>
-              <a:t>5. Subscriptions: Recurring payment tracker with review recommendations.</a:t>
-            </a:r>
-          </a:p>
-          <a:p>
-            <a:pPr>
-              <a:defRPr sz="1500">
-                <a:solidFill>
-                  <a:srgbClr val="F8FAFC"/>
-                </a:solidFill>
-              </a:defRPr>
-            </a:pPr>
-            <a:r>
-              <a:t>6. Planning &amp; Simulator: Budget limits, savings goal progress, and 50% spend cut simulations.</a:t>
-            </a:r>
-          </a:p>
-        </p:txBody>
-      </p:sp>
-    </p:spTree>
-  </p:cSld>
-  <p:clrMapOvr>
-    <a:masterClrMapping/>
-  </p:clrMapOvr>
-</p:sld>
-</file>
-
-<file path=ppt/slides/slide5.xml><?xml version="1.0" encoding="utf-8"?>
-<p:sld xmlns:a="http://schemas.openxmlformats.org/drawingml/2006/main" xmlns:p="http://schemas.openxmlformats.org/presentationml/2006/main" xmlns:r="http://schemas.openxmlformats.org/officeDocument/2006/relationships">
-  <p:cSld>
-    <p:bg>
-      <p:bgPr>
-        <a:solidFill>
-          <a:srgbClr val="0F172A"/>
-        </a:solidFill>
-        <a:effectLst/>
-      </p:bgPr>
-    </p:bg>
-    <p:spTree>
-      <p:nvGrpSpPr>
-        <p:cNvPr id="1" name=""/>
-        <p:cNvGrpSpPr/>
-        <p:nvPr/>
-      </p:nvGrpSpPr>
-      <p:grpSpPr/>
-      <p:sp>
-        <p:nvSpPr>
-          <p:cNvPr id="2" name="TextBox 1"/>
-          <p:cNvSpPr txBox="1"/>
-          <p:nvPr/>
-        </p:nvSpPr>
-        <p:spPr>
-          <a:xfrm>
-            <a:off x="731520" y="457200"/>
-            <a:ext cx="10698480" cy="1097280"/>
-          </a:xfrm>
-          <a:prstGeom prst="rect">
-            <a:avLst/>
-          </a:prstGeom>
-          <a:noFill/>
-        </p:spPr>
-        <p:txBody>
-          <a:bodyPr wrap="square">
-            <a:spAutoFit/>
-          </a:bodyPr>
-          <a:lstStyle/>
-          <a:p>
-            <a:pPr>
-              <a:defRPr sz="1200" b="1">
-                <a:solidFill>
-                  <a:srgbClr val="C084FC"/>
-                </a:solidFill>
-              </a:defRPr>
-            </a:pPr>
-            <a:r>
-              <a:t>FINLY — SMART EXPENSE ANALYZER &amp; FINANCIAL HEALTH DASHBOARD</a:t>
-            </a:r>
-          </a:p>
-          <a:p>
-            <a:pPr>
-              <a:defRPr sz="2800" b="1">
-                <a:solidFill>
-                  <a:srgbClr val="F8FAFC"/>
-                </a:solidFill>
-              </a:defRPr>
-            </a:pPr>
-            <a:r>
-              <a:t>Security Model &amp; Audit Compliance</a:t>
-            </a:r>
-          </a:p>
-        </p:txBody>
-      </p:sp>
-      <p:sp>
-        <p:nvSpPr>
-          <p:cNvPr id="3" name="TextBox 2"/>
-          <p:cNvSpPr txBox="1"/>
-          <p:nvPr/>
-        </p:nvSpPr>
-        <p:spPr>
-          <a:xfrm>
-            <a:off x="731520" y="1828800"/>
-            <a:ext cx="10698480" cy="4389120"/>
-          </a:xfrm>
-          <a:prstGeom prst="rect">
-            <a:avLst/>
-          </a:prstGeom>
-          <a:noFill/>
-        </p:spPr>
-        <p:txBody>
-          <a:bodyPr wrap="square">
-            <a:spAutoFit/>
-          </a:bodyPr>
-          <a:lstStyle/>
-          <a:p/>
-          <a:p>
-            <a:pPr>
-              <a:defRPr sz="1600">
-                <a:solidFill>
-                  <a:srgbClr val="F8FAFC"/>
-                </a:solidFill>
-              </a:defRPr>
-            </a:pPr>
-            <a:r>
-              <a:t>🛡️ Backend Secret Protection: GROQ_API_KEY stored backend-only (.env listed in .gitignore).</a:t>
-            </a:r>
-          </a:p>
-          <a:p>
-            <a:pPr>
-              <a:defRPr sz="1600">
-                <a:solidFill>
-                  <a:srgbClr val="F8FAFC"/>
-                </a:solidFill>
-              </a:defRPr>
-            </a:pPr>
-            <a:r>
-              <a:t>🛡️ Multi-Tenant Isolation: Tools run exclusively against authenticated user ID payload.</a:t>
-            </a:r>
-          </a:p>
-          <a:p>
-            <a:pPr>
-              <a:defRPr sz="1600">
-                <a:solidFill>
-                  <a:srgbClr val="F8FAFC"/>
-                </a:solidFill>
-              </a:defRPr>
-            </a:pPr>
-            <a:r>
-              <a:t>🛡️ Database Security: Supabase PostgreSQL with Row Level Security (RLS) policies.</a:t>
-            </a:r>
-          </a:p>
-          <a:p>
-            <a:pPr>
-              <a:defRPr sz="1600">
-                <a:solidFill>
-                  <a:srgbClr val="F8FAFC"/>
-                </a:solidFill>
-              </a:defRPr>
-            </a:pPr>
-            <a:r>
-              <a:t>🛡️ Code Quality: Clean Oxlint linting ruleset (0 errors), 100% Vite production build.</a:t>
-            </a:r>
-          </a:p>
-          <a:p>
-            <a:pPr>
-              <a:defRPr sz="1600">
-                <a:solidFill>
-                  <a:srgbClr val="F8FAFC"/>
-                </a:solidFill>
-              </a:defRPr>
-            </a:pPr>
-            <a:r>
-              <a:t>🛡️ Automated Test Suite: tests/agent.test.js passing 12/12 unit and security tests.</a:t>
             </a:r>
           </a:p>
         </p:txBody>

</xml_diff>